<commit_message>
Remove emojis across codebase and presentation files
</commit_message>
<xml_diff>
--- a/outputs/presentation.pptx
+++ b/outputs/presentation.pptx
@@ -3492,7 +3492,7 @@
               </a:defRPr>
             </a:pPr>
             <a:r>
-              <a:t>✔ 0. Nominal Pass</a:t>
+              <a:t>- 0. Nominal Pass</a:t>
             </a:r>
           </a:p>
           <a:p>
@@ -3519,7 +3519,7 @@
               </a:defRPr>
             </a:pPr>
             <a:r>
-              <a:t>✔ 1. Under-Etch</a:t>
+              <a:t>- 1. Under-Etch</a:t>
             </a:r>
           </a:p>
           <a:p>
@@ -3546,7 +3546,7 @@
               </a:defRPr>
             </a:pPr>
             <a:r>
-              <a:t>✔ 2. Over-Etch</a:t>
+              <a:t>- 2. Over-Etch</a:t>
             </a:r>
           </a:p>
           <a:p>
@@ -3573,7 +3573,7 @@
               </a:defRPr>
             </a:pPr>
             <a:r>
-              <a:t>✔ 3. Particulate Contamination</a:t>
+              <a:t>- 3. Particulate Contamination</a:t>
             </a:r>
           </a:p>
           <a:p>
@@ -3600,7 +3600,7 @@
               </a:defRPr>
             </a:pPr>
             <a:r>
-              <a:t>✔ 4. Litho Defocus / Bridging</a:t>
+              <a:t>- 4. Litho Defocus / Bridging</a:t>
             </a:r>
           </a:p>
           <a:p>
@@ -3627,7 +3627,7 @@
               </a:defRPr>
             </a:pPr>
             <a:r>
-              <a:t>✔ 5. CMP Microscratch / Void</a:t>
+              <a:t>- 5. CMP Microscratch / Void</a:t>
             </a:r>
           </a:p>
           <a:p>
@@ -3654,7 +3654,7 @@
               </a:defRPr>
             </a:pPr>
             <a:r>
-              <a:t>✔ 6. Incomplete Deposition</a:t>
+              <a:t>- 6. Incomplete Deposition</a:t>
             </a:r>
           </a:p>
           <a:p>
@@ -3804,7 +3804,7 @@
               </a:defRPr>
             </a:pPr>
             <a:r>
-              <a:t>🔹 Spectroscopic Ellipsometry</a:t>
+              <a:t>• Spectroscopic Ellipsometry</a:t>
             </a:r>
           </a:p>
           <a:p>
@@ -3831,7 +3831,7 @@
               </a:defRPr>
             </a:pPr>
             <a:r>
-              <a:t>🔹 AFM Surface Topography</a:t>
+              <a:t>• AFM Surface Topography</a:t>
             </a:r>
           </a:p>
           <a:p>
@@ -3858,7 +3858,7 @@
               </a:defRPr>
             </a:pPr>
             <a:r>
-              <a:t>🔹 Electrical In-Line Metrology</a:t>
+              <a:t>• Electrical In-Line Metrology</a:t>
             </a:r>
           </a:p>
           <a:p>
@@ -3885,7 +3885,7 @@
               </a:defRPr>
             </a:pPr>
             <a:r>
-              <a:t>🔹 CD-SEM &amp; Defect Inspection</a:t>
+              <a:t>• CD-SEM &amp; Defect Inspection</a:t>
             </a:r>
           </a:p>
           <a:p>
@@ -4330,7 +4330,7 @@
               </a:defRPr>
             </a:pPr>
             <a:r>
-              <a:t>🏆 Random Forest (Champion)</a:t>
+              <a:t>1. Random Forest (Champion)</a:t>
             </a:r>
           </a:p>
           <a:p>
@@ -4361,7 +4361,7 @@
               </a:defRPr>
             </a:pPr>
             <a:r>
-              <a:t>⚡ XGBoost Classifier</a:t>
+              <a:t>2. XGBoost Classifier</a:t>
             </a:r>
           </a:p>
           <a:p>
@@ -4392,7 +4392,7 @@
               </a:defRPr>
             </a:pPr>
             <a:r>
-              <a:t>🛡️ Support Vector Machine (RBF)</a:t>
+              <a:t>3. Support Vector Machine (RBF)</a:t>
             </a:r>
           </a:p>
           <a:p>
@@ -4423,7 +4423,7 @@
               </a:defRPr>
             </a:pPr>
             <a:r>
-              <a:t>🧠 MLP Deep Neural Network</a:t>
+              <a:t>4. MLP Deep Neural Network</a:t>
             </a:r>
           </a:p>
           <a:p>
@@ -4454,7 +4454,7 @@
               </a:defRPr>
             </a:pPr>
             <a:r>
-              <a:t>📊 Calibrated Baseline (LogReg)</a:t>
+              <a:t>5. Logistic Regression Baseline</a:t>
             </a:r>
           </a:p>
           <a:p>
@@ -4632,7 +4632,7 @@
               </a:defRPr>
             </a:pPr>
             <a:r>
-              <a:t>✔ Multi-Modal Metrology Synergy:</a:t>
+              <a:t>- Multi-Modal Metrology Synergy:</a:t>
             </a:r>
           </a:p>
           <a:p>
@@ -4659,7 +4659,7 @@
               </a:defRPr>
             </a:pPr>
             <a:r>
-              <a:t>✔ Physical Interpretability:</a:t>
+              <a:t>- Physical Interpretability:</a:t>
             </a:r>
           </a:p>
           <a:p>
@@ -4686,7 +4686,7 @@
               </a:defRPr>
             </a:pPr>
             <a:r>
-              <a:t>✔ Real-Time Execution Speed:</a:t>
+              <a:t>- Real-Time Execution Speed:</a:t>
             </a:r>
           </a:p>
           <a:p>
@@ -4748,7 +4748,7 @@
               </a:defRPr>
             </a:pPr>
             <a:r>
-              <a:t>🚀 Edge AI Tool Controllers:</a:t>
+              <a:t>- Edge AI Tool Controllers:</a:t>
             </a:r>
           </a:p>
           <a:p>
@@ -4775,7 +4775,7 @@
               </a:defRPr>
             </a:pPr>
             <a:r>
-              <a:t>🚀 Wafer-Map Spatial CNNs:</a:t>
+              <a:t>- Wafer-Map Spatial CNNs:</a:t>
             </a:r>
           </a:p>
           <a:p>
@@ -4802,7 +4802,7 @@
               </a:defRPr>
             </a:pPr>
             <a:r>
-              <a:t>🚀 Active Cleanroom Transfer:</a:t>
+              <a:t>- Active Cleanroom Transfer:</a:t>
             </a:r>
           </a:p>
           <a:p>

</xml_diff>